<commit_message>
add mohit backend to fastapi backend
</commit_message>
<xml_diff>
--- a/Assets/SIH-2026-VALIDRA.pptx
+++ b/Assets/SIH-2026-VALIDRA.pptx
@@ -141,7 +141,7 @@
           <a:p>
             <a:fld id="{1321ABF4-2A27-4B4A-B42C-D07480745A19}" type="datetimeFigureOut">
               <a:rPr lang="en-IN" smtClean="0"/>
-              <a:t>16-09-2026</a:t>
+              <a:t>17-09-2026</a:t>
             </a:fld>
             <a:endParaRPr lang="en-IN" dirty="0"/>
           </a:p>
@@ -15083,7 +15083,7 @@
           </a:bodyPr>
           <a:lstStyle/>
           <a:p>
-            <a:pPr>
+            <a:pPr algn="ctr">
               <a:lnSpc>
                 <a:spcPct val="100000"/>
               </a:lnSpc>
@@ -15099,7 +15099,7 @@
                 <a:latin typeface="Calibri"/>
                 <a:cs typeface="Calibri"/>
               </a:rPr>
-              <a:t>OCR.SPACE</a:t>
+              <a:t>OCR</a:t>
             </a:r>
             <a:endParaRPr sz="750" dirty="0">
               <a:latin typeface="Calibri"/>
@@ -15301,7 +15301,7 @@
         <p:spPr>
           <a:xfrm>
             <a:off x="787539" y="3930192"/>
-            <a:ext cx="650240" cy="286385"/>
+            <a:ext cx="650240" cy="269304"/>
           </a:xfrm>
           <a:prstGeom prst="rect">
             <a:avLst/>
@@ -15363,34 +15363,14 @@
               <a:t> </a:t>
             </a:r>
             <a:r>
-              <a:rPr sz="900" b="1" dirty="0">
+              <a:rPr lang="en-US" sz="900" b="1" spc="-25" dirty="0">
                 <a:solidFill>
                   <a:srgbClr val="FFFFFF"/>
                 </a:solidFill>
                 <a:latin typeface="Calibri"/>
                 <a:cs typeface="Calibri"/>
               </a:rPr>
-              <a:t>+</a:t>
-            </a:r>
-            <a:r>
-              <a:rPr sz="900" b="1" spc="-20" dirty="0">
-                <a:solidFill>
-                  <a:srgbClr val="FFFFFF"/>
-                </a:solidFill>
-                <a:latin typeface="Calibri"/>
-                <a:cs typeface="Calibri"/>
-              </a:rPr>
-              <a:t> </a:t>
-            </a:r>
-            <a:r>
-              <a:rPr sz="900" b="1" spc="-25" dirty="0">
-                <a:solidFill>
-                  <a:srgbClr val="FFFFFF"/>
-                </a:solidFill>
-                <a:latin typeface="Calibri"/>
-                <a:cs typeface="Calibri"/>
-              </a:rPr>
-              <a:t>RAG</a:t>
+              <a:t>Engine</a:t>
             </a:r>
             <a:endParaRPr sz="900" dirty="0">
               <a:latin typeface="Calibri"/>
@@ -15706,7 +15686,7 @@
         </p:nvSpPr>
         <p:spPr>
           <a:xfrm>
-            <a:off x="2071063" y="4518143"/>
+            <a:off x="2037344" y="4526621"/>
             <a:ext cx="454659" cy="139700"/>
           </a:xfrm>
           <a:prstGeom prst="rect">
@@ -15752,7 +15732,7 @@
         </p:nvSpPr>
         <p:spPr>
           <a:xfrm>
-            <a:off x="3984663" y="4514316"/>
+            <a:off x="3986651" y="4515408"/>
             <a:ext cx="586105" cy="139700"/>
           </a:xfrm>
           <a:prstGeom prst="rect">
@@ -15818,7 +15798,7 @@
         </p:nvSpPr>
         <p:spPr>
           <a:xfrm>
-            <a:off x="2892595" y="4520046"/>
+            <a:off x="2887240" y="4526621"/>
             <a:ext cx="1021386" cy="128240"/>
           </a:xfrm>
           <a:prstGeom prst="rect">
@@ -15864,7 +15844,7 @@
         </p:nvSpPr>
         <p:spPr>
           <a:xfrm>
-            <a:off x="4842037" y="4508281"/>
+            <a:off x="4859568" y="4526621"/>
             <a:ext cx="415290" cy="139700"/>
           </a:xfrm>
           <a:prstGeom prst="rect">
@@ -17152,7 +17132,7 @@
                 <a:latin typeface="Calibri"/>
                 <a:cs typeface="Calibri"/>
               </a:rPr>
-              <a:t>Python · Rule-based validation · Compliance checks</a:t>
+              <a:t>Python</a:t>
             </a:r>
             <a:endParaRPr sz="900" dirty="0">
               <a:latin typeface="Calibri"/>
@@ -24835,7 +24815,27 @@
                 <a:latin typeface="Calibri"/>
                 <a:cs typeface="Calibri"/>
               </a:rPr>
-              <a:t> Built using mature technologies: Next.js, FastAPI, OpenCV, PaddleOCR and PostgreSQL</a:t>
+              <a:t> Built using mature technologies: Next.js, FastAPI, OpenCV, </a:t>
+            </a:r>
+            <a:r>
+              <a:rPr lang="en-US" altLang="en-US" sz="900" spc="-10" dirty="0" err="1">
+                <a:solidFill>
+                  <a:srgbClr val="2A3544"/>
+                </a:solidFill>
+                <a:latin typeface="Calibri"/>
+                <a:cs typeface="Calibri"/>
+              </a:rPr>
+              <a:t>EasyOCR</a:t>
+            </a:r>
+            <a:r>
+              <a:rPr lang="en-US" altLang="en-US" sz="900" spc="-10" dirty="0">
+                <a:solidFill>
+                  <a:srgbClr val="2A3544"/>
+                </a:solidFill>
+                <a:latin typeface="Calibri"/>
+                <a:cs typeface="Calibri"/>
+              </a:rPr>
+              <a:t> and PostgreSQL</a:t>
             </a:r>
             <a:r>
               <a:rPr kumimoji="0" lang="en-US" altLang="en-US" sz="900" b="0" i="0" u="none" strike="noStrike" cap="none" normalizeH="0" baseline="0" dirty="0">
@@ -31435,6 +31435,16 @@
               </a:tabLst>
             </a:pPr>
             <a:r>
+              <a:rPr lang="en-US" sz="1000" dirty="0" err="1">
+                <a:solidFill>
+                  <a:srgbClr val="2A3544"/>
+                </a:solidFill>
+                <a:latin typeface="Calibri"/>
+                <a:cs typeface="Calibri"/>
+              </a:rPr>
+              <a:t>OCR.space</a:t>
+            </a:r>
+            <a:r>
               <a:rPr lang="en-US" sz="1000" dirty="0">
                 <a:solidFill>
                   <a:srgbClr val="2A3544"/>
@@ -31442,7 +31452,7 @@
                 <a:latin typeface="Calibri"/>
                 <a:cs typeface="Calibri"/>
               </a:rPr>
-              <a:t>OCR.space API — image-to-text extraction and OCR result overlays</a:t>
+              <a:t> API — image-to-text extraction and OCR result overlays</a:t>
             </a:r>
           </a:p>
           <a:p>

</xml_diff>